<commit_message>
Final deck: replace closing-slide stats with GitHub repo link
Co-Authored-By: Claude Opus 5.5 <noreply@anthropic.com>
</commit_message>
<xml_diff>
--- a/final/Bengaluru_Urban_Mobility_Presentation_12_Slides.pptx
+++ b/final/Bengaluru_Urban_Mobility_Presentation_12_Slides.pptx
@@ -4320,904 +4320,7 @@
 </p:sld>
 </file>
 
-<file path=ppt/slides/slide11.xml><?xml version="1.0" encoding="utf-8"?>
-<p:sld xmlns:a="http://schemas.openxmlformats.org/drawingml/2006/main" xmlns:r="http://schemas.openxmlformats.org/officeDocument/2006/relationships" xmlns:p="http://schemas.openxmlformats.org/presentationml/2006/main">
-  <p:cSld name="Slide 11">
-    <p:spTree>
-      <p:nvGrpSpPr>
-        <p:cNvPr id="1" name=""/>
-        <p:cNvGrpSpPr/>
-        <p:nvPr/>
-      </p:nvGrpSpPr>
-      <p:grpSpPr>
-        <a:xfrm>
-          <a:off x="0" y="0"/>
-          <a:ext cx="0" cy="0"/>
-          <a:chOff x="0" y="0"/>
-          <a:chExt cx="0" cy="0"/>
-        </a:xfrm>
-      </p:grpSpPr>
-      <p:sp>
-        <p:nvSpPr>
-          <p:cNvPr id="2" name="Text 0"/>
-          <p:cNvSpPr txBox="1"/>
-          <p:nvPr/>
-        </p:nvSpPr>
-        <p:spPr>
-          <a:xfrm>
-            <a:off x="457200" y="274320"/>
-            <a:ext cx="8229600" cy="274320"/>
-          </a:xfrm>
-          <a:prstGeom prst="rect">
-            <a:avLst/>
-          </a:prstGeom>
-          <a:noFill/>
-          <a:ln/>
-        </p:spPr>
-        <p:txBody>
-          <a:bodyPr wrap="square" lIns="0" tIns="0" rIns="0" bIns="0" rtlCol="0" anchor="ctr"/>
-          <a:lstStyle/>
-          <a:p>
-            <a:pPr indent="0" marL="0">
-              <a:buNone/>
-            </a:pPr>
-            <a:r>
-              <a:rPr lang="en-US" sz="1000" b="1" spc="300" kern="0" dirty="0">
-                <a:solidFill>
-                  <a:srgbClr val="A65F00"/>
-                </a:solidFill>
-                <a:latin typeface="Calibri" pitchFamily="34" charset="0"/>
-                <a:ea typeface="Calibri" pitchFamily="34" charset="-122"/>
-                <a:cs typeface="Calibri" pitchFamily="34" charset="-120"/>
-              </a:rPr>
-              <a:t>STAGE 4</a:t>
-            </a:r>
-            <a:endParaRPr lang="en-US" sz="1000" dirty="0"/>
-          </a:p>
-        </p:txBody>
-      </p:sp>
-      <p:sp>
-        <p:nvSpPr>
-          <p:cNvPr id="3" name="Text 1"/>
-          <p:cNvSpPr txBox="1"/>
-          <p:nvPr/>
-        </p:nvSpPr>
-        <p:spPr>
-          <a:xfrm>
-            <a:off x="457200" y="530352"/>
-            <a:ext cx="8229600" cy="548640"/>
-          </a:xfrm>
-          <a:prstGeom prst="rect">
-            <a:avLst/>
-          </a:prstGeom>
-          <a:noFill/>
-          <a:ln/>
-        </p:spPr>
-        <p:txBody>
-          <a:bodyPr wrap="square" lIns="0" tIns="0" rIns="0" bIns="0" rtlCol="0" anchor="ctr"/>
-          <a:lstStyle/>
-          <a:p>
-            <a:pPr indent="0" marL="0">
-              <a:buNone/>
-            </a:pPr>
-            <a:r>
-              <a:rPr lang="en-US" sz="2800" b="1" dirty="0">
-                <a:solidFill>
-                  <a:srgbClr val="14213D"/>
-                </a:solidFill>
-                <a:latin typeface="Cambria" pitchFamily="34" charset="0"/>
-                <a:ea typeface="Cambria" pitchFamily="34" charset="-122"/>
-                <a:cs typeface="Cambria" pitchFamily="34" charset="-120"/>
-              </a:rPr>
-              <a:t>Machine learning models</a:t>
-            </a:r>
-            <a:endParaRPr lang="en-US" sz="2800" dirty="0"/>
-          </a:p>
-        </p:txBody>
-      </p:sp>
-      <p:sp>
-        <p:nvSpPr>
-          <p:cNvPr id="4" name="Shape 2"/>
-          <p:cNvSpPr/>
-          <p:nvPr/>
-        </p:nvSpPr>
-        <p:spPr>
-          <a:xfrm>
-            <a:off x="457200" y="1188720"/>
-            <a:ext cx="4023360" cy="3337560"/>
-          </a:xfrm>
-          <a:prstGeom prst="roundRect">
-            <a:avLst>
-              <a:gd name="adj" fmla="val 2192"/>
-            </a:avLst>
-          </a:prstGeom>
-          <a:solidFill>
-            <a:srgbClr val="EEF2F7"/>
-          </a:solidFill>
-          <a:ln w="12700">
-            <a:solidFill>
-              <a:srgbClr val="EEF2F7"/>
-            </a:solidFill>
-            <a:prstDash val="solid"/>
-          </a:ln>
-        </p:spPr>
-      </p:sp>
-      <p:sp>
-        <p:nvSpPr>
-          <p:cNvPr id="5" name="Text 3"/>
-          <p:cNvSpPr txBox="1"/>
-          <p:nvPr/>
-        </p:nvSpPr>
-        <p:spPr>
-          <a:xfrm>
-            <a:off x="685800" y="1325880"/>
-            <a:ext cx="3566160" cy="228600"/>
-          </a:xfrm>
-          <a:prstGeom prst="rect">
-            <a:avLst/>
-          </a:prstGeom>
-          <a:noFill/>
-          <a:ln/>
-        </p:spPr>
-        <p:txBody>
-          <a:bodyPr wrap="square" lIns="0" tIns="0" rIns="0" bIns="0" rtlCol="0" anchor="ctr"/>
-          <a:lstStyle/>
-          <a:p>
-            <a:pPr indent="0" marL="0">
-              <a:buNone/>
-            </a:pPr>
-            <a:r>
-              <a:rPr lang="en-US" sz="950" b="1" spc="200" kern="0" dirty="0">
-                <a:solidFill>
-                  <a:srgbClr val="A65F00"/>
-                </a:solidFill>
-              </a:rPr>
-              <a:t>MODEL A — REGRESSION</a:t>
-            </a:r>
-            <a:endParaRPr lang="en-US" sz="950" dirty="0"/>
-          </a:p>
-        </p:txBody>
-      </p:sp>
-      <p:sp>
-        <p:nvSpPr>
-          <p:cNvPr id="6" name="Text 4"/>
-          <p:cNvSpPr txBox="1"/>
-          <p:nvPr/>
-        </p:nvSpPr>
-        <p:spPr>
-          <a:xfrm>
-            <a:off x="685800" y="1572768"/>
-            <a:ext cx="3566160" cy="365760"/>
-          </a:xfrm>
-          <a:prstGeom prst="rect">
-            <a:avLst/>
-          </a:prstGeom>
-          <a:noFill/>
-          <a:ln/>
-        </p:spPr>
-        <p:txBody>
-          <a:bodyPr wrap="square" lIns="0" tIns="0" rIns="0" bIns="0" rtlCol="0" anchor="ctr"/>
-          <a:lstStyle/>
-          <a:p>
-            <a:pPr indent="0" marL="0">
-              <a:buNone/>
-            </a:pPr>
-            <a:r>
-              <a:rPr lang="en-US" sz="1700" b="1" dirty="0">
-                <a:solidFill>
-                  <a:srgbClr val="14213D"/>
-                </a:solidFill>
-                <a:latin typeface="Cambria" pitchFamily="34" charset="0"/>
-                <a:ea typeface="Cambria" pitchFamily="34" charset="-122"/>
-                <a:cs typeface="Cambria" pitchFamily="34" charset="-120"/>
-              </a:rPr>
-              <a:t>Trip duration (ETA)</a:t>
-            </a:r>
-            <a:endParaRPr lang="en-US" sz="1700" dirty="0"/>
-          </a:p>
-        </p:txBody>
-      </p:sp>
-      <p:sp>
-        <p:nvSpPr>
-          <p:cNvPr id="7" name="Text 5"/>
-          <p:cNvSpPr txBox="1"/>
-          <p:nvPr/>
-        </p:nvSpPr>
-        <p:spPr>
-          <a:xfrm>
-            <a:off x="685800" y="1938528"/>
-            <a:ext cx="3566160" cy="256032"/>
-          </a:xfrm>
-          <a:prstGeom prst="rect">
-            <a:avLst/>
-          </a:prstGeom>
-          <a:noFill/>
-          <a:ln/>
-        </p:spPr>
-        <p:txBody>
-          <a:bodyPr wrap="square" lIns="0" tIns="0" rIns="0" bIns="0" rtlCol="0" anchor="ctr"/>
-          <a:lstStyle/>
-          <a:p>
-            <a:pPr indent="0" marL="0">
-              <a:buNone/>
-            </a:pPr>
-            <a:r>
-              <a:rPr lang="en-US" sz="1100" i="1" dirty="0">
-                <a:solidFill>
-                  <a:srgbClr val="5B6577"/>
-                </a:solidFill>
-              </a:rPr>
-              <a:t>Random Forest regressor · 80 trees, depth 12</a:t>
-            </a:r>
-            <a:endParaRPr lang="en-US" sz="1100" dirty="0"/>
-          </a:p>
-        </p:txBody>
-      </p:sp>
-      <p:sp>
-        <p:nvSpPr>
-          <p:cNvPr id="8" name="Text 6"/>
-          <p:cNvSpPr txBox="1"/>
-          <p:nvPr/>
-        </p:nvSpPr>
-        <p:spPr>
-          <a:xfrm>
-            <a:off x="685800" y="2258568"/>
-            <a:ext cx="3611880" cy="1188720"/>
-          </a:xfrm>
-          <a:prstGeom prst="rect">
-            <a:avLst/>
-          </a:prstGeom>
-          <a:noFill/>
-          <a:ln/>
-        </p:spPr>
-        <p:txBody>
-          <a:bodyPr wrap="square" lIns="0" tIns="0" rIns="0" bIns="0" rtlCol="0" anchor="t"/>
-          <a:lstStyle/>
-          <a:p>
-            <a:pPr marL="342900" indent="-342900">
-              <a:spcAft>
-                <a:spcPts val="600"/>
-              </a:spcAft>
-              <a:buSzPct val="100000"/>
-              <a:buChar char="•"/>
-            </a:pPr>
-            <a:r>
-              <a:rPr lang="en-US" sz="1150" dirty="0">
-                <a:solidFill>
-                  <a:srgbClr val="1B2433"/>
-                </a:solidFill>
-                <a:latin typeface="Calibri" pitchFamily="34" charset="0"/>
-                <a:ea typeface="Calibri" pitchFamily="34" charset="-122"/>
-                <a:cs typeface="Calibri" pitchFamily="34" charset="-120"/>
-              </a:rPr>
-              <a:t>Features: vehicle, distance, hour, day, traffic factor, rain</a:t>
-            </a:r>
-            <a:endParaRPr lang="en-US" sz="1150" dirty="0"/>
-          </a:p>
-          <a:p>
-            <a:pPr marL="342900" indent="-342900">
-              <a:spcAft>
-                <a:spcPts val="600"/>
-              </a:spcAft>
-              <a:buSzPct val="100000"/>
-              <a:buChar char="•"/>
-            </a:pPr>
-            <a:r>
-              <a:rPr lang="en-US" sz="1150" dirty="0">
-                <a:solidFill>
-                  <a:srgbClr val="1B2433"/>
-                </a:solidFill>
-                <a:latin typeface="Calibri" pitchFamily="34" charset="0"/>
-                <a:ea typeface="Calibri" pitchFamily="34" charset="-122"/>
-                <a:cs typeface="Calibri" pitchFamily="34" charset="-120"/>
-              </a:rPr>
-              <a:t>Learns actual ÷ formula ETA, so long trips still scale by vehicle</a:t>
-            </a:r>
-            <a:endParaRPr lang="en-US" sz="1150" dirty="0"/>
-          </a:p>
-          <a:p>
-            <a:pPr marL="342900" indent="-342900">
-              <a:spcAft>
-                <a:spcPts val="600"/>
-              </a:spcAft>
-              <a:buSzPct val="100000"/>
-              <a:buChar char="•"/>
-            </a:pPr>
-            <a:r>
-              <a:rPr lang="en-US" sz="1150" dirty="0">
-                <a:solidFill>
-                  <a:srgbClr val="1B2433"/>
-                </a:solidFill>
-                <a:latin typeface="Calibri" pitchFamily="34" charset="0"/>
-                <a:ea typeface="Calibri" pitchFamily="34" charset="-122"/>
-                <a:cs typeface="Calibri" pitchFamily="34" charset="-120"/>
-              </a:rPr>
-              <a:t>Fare is then computed from the ETA via the rate card</a:t>
-            </a:r>
-            <a:endParaRPr lang="en-US" sz="1150" dirty="0"/>
-          </a:p>
-        </p:txBody>
-      </p:sp>
-      <p:sp>
-        <p:nvSpPr>
-          <p:cNvPr id="9" name="Text 7"/>
-          <p:cNvSpPr txBox="1"/>
-          <p:nvPr/>
-        </p:nvSpPr>
-        <p:spPr>
-          <a:xfrm>
-            <a:off x="594360" y="3566160"/>
-            <a:ext cx="1828800" cy="457200"/>
-          </a:xfrm>
-          <a:prstGeom prst="rect">
-            <a:avLst/>
-          </a:prstGeom>
-          <a:noFill/>
-          <a:ln/>
-        </p:spPr>
-        <p:txBody>
-          <a:bodyPr wrap="square" lIns="0" tIns="0" rIns="0" bIns="0" rtlCol="0" anchor="ctr"/>
-          <a:lstStyle/>
-          <a:p>
-            <a:pPr algn="ctr" indent="0" marL="0">
-              <a:buNone/>
-            </a:pPr>
-            <a:r>
-              <a:rPr lang="en-US" sz="2200" b="1" dirty="0">
-                <a:solidFill>
-                  <a:srgbClr val="1B2433"/>
-                </a:solidFill>
-                <a:latin typeface="Cambria" pitchFamily="34" charset="0"/>
-                <a:ea typeface="Cambria" pitchFamily="34" charset="-122"/>
-                <a:cs typeface="Cambria" pitchFamily="34" charset="-120"/>
-              </a:rPr>
-              <a:t>2.995 min</a:t>
-            </a:r>
-            <a:endParaRPr lang="en-US" sz="2200" dirty="0"/>
-          </a:p>
-        </p:txBody>
-      </p:sp>
-      <p:sp>
-        <p:nvSpPr>
-          <p:cNvPr id="10" name="Text 8"/>
-          <p:cNvSpPr txBox="1"/>
-          <p:nvPr/>
-        </p:nvSpPr>
-        <p:spPr>
-          <a:xfrm>
-            <a:off x="594360" y="4023360"/>
-            <a:ext cx="1828800" cy="274320"/>
-          </a:xfrm>
-          <a:prstGeom prst="rect">
-            <a:avLst/>
-          </a:prstGeom>
-          <a:noFill/>
-          <a:ln/>
-        </p:spPr>
-        <p:txBody>
-          <a:bodyPr wrap="square" lIns="0" tIns="0" rIns="0" bIns="0" rtlCol="0" anchor="ctr"/>
-          <a:lstStyle/>
-          <a:p>
-            <a:pPr algn="ctr" indent="0" marL="0">
-              <a:buNone/>
-            </a:pPr>
-            <a:r>
-              <a:rPr lang="en-US" sz="1050" dirty="0">
-                <a:solidFill>
-                  <a:srgbClr val="5B6577"/>
-                </a:solidFill>
-              </a:rPr>
-              <a:t>Mean absolute error</a:t>
-            </a:r>
-            <a:endParaRPr lang="en-US" sz="1050" dirty="0"/>
-          </a:p>
-        </p:txBody>
-      </p:sp>
-      <p:sp>
-        <p:nvSpPr>
-          <p:cNvPr id="11" name="Text 9"/>
-          <p:cNvSpPr txBox="1"/>
-          <p:nvPr/>
-        </p:nvSpPr>
-        <p:spPr>
-          <a:xfrm>
-            <a:off x="2468880" y="3566160"/>
-            <a:ext cx="1828800" cy="457200"/>
-          </a:xfrm>
-          <a:prstGeom prst="rect">
-            <a:avLst/>
-          </a:prstGeom>
-          <a:noFill/>
-          <a:ln/>
-        </p:spPr>
-        <p:txBody>
-          <a:bodyPr wrap="square" lIns="0" tIns="0" rIns="0" bIns="0" rtlCol="0" anchor="ctr"/>
-          <a:lstStyle/>
-          <a:p>
-            <a:pPr algn="ctr" indent="0" marL="0">
-              <a:buNone/>
-            </a:pPr>
-            <a:r>
-              <a:rPr lang="en-US" sz="2200" b="1" dirty="0">
-                <a:solidFill>
-                  <a:srgbClr val="1B2433"/>
-                </a:solidFill>
-                <a:latin typeface="Cambria" pitchFamily="34" charset="0"/>
-                <a:ea typeface="Cambria" pitchFamily="34" charset="-122"/>
-                <a:cs typeface="Cambria" pitchFamily="34" charset="-120"/>
-              </a:rPr>
-              <a:t>0.957</a:t>
-            </a:r>
-            <a:endParaRPr lang="en-US" sz="2200" dirty="0"/>
-          </a:p>
-        </p:txBody>
-      </p:sp>
-      <p:sp>
-        <p:nvSpPr>
-          <p:cNvPr id="12" name="Text 10"/>
-          <p:cNvSpPr txBox="1"/>
-          <p:nvPr/>
-        </p:nvSpPr>
-        <p:spPr>
-          <a:xfrm>
-            <a:off x="2468880" y="4023360"/>
-            <a:ext cx="1828800" cy="274320"/>
-          </a:xfrm>
-          <a:prstGeom prst="rect">
-            <a:avLst/>
-          </a:prstGeom>
-          <a:noFill/>
-          <a:ln/>
-        </p:spPr>
-        <p:txBody>
-          <a:bodyPr wrap="square" lIns="0" tIns="0" rIns="0" bIns="0" rtlCol="0" anchor="ctr"/>
-          <a:lstStyle/>
-          <a:p>
-            <a:pPr algn="ctr" indent="0" marL="0">
-              <a:buNone/>
-            </a:pPr>
-            <a:r>
-              <a:rPr lang="en-US" sz="1050" dirty="0">
-                <a:solidFill>
-                  <a:srgbClr val="5B6577"/>
-                </a:solidFill>
-              </a:rPr>
-              <a:t>R² score</a:t>
-            </a:r>
-            <a:endParaRPr lang="en-US" sz="1050" dirty="0"/>
-          </a:p>
-        </p:txBody>
-      </p:sp>
-      <p:sp>
-        <p:nvSpPr>
-          <p:cNvPr id="13" name="Shape 11"/>
-          <p:cNvSpPr/>
-          <p:nvPr/>
-        </p:nvSpPr>
-        <p:spPr>
-          <a:xfrm>
-            <a:off x="4663440" y="1188720"/>
-            <a:ext cx="4023360" cy="3337560"/>
-          </a:xfrm>
-          <a:prstGeom prst="roundRect">
-            <a:avLst>
-              <a:gd name="adj" fmla="val 2192"/>
-            </a:avLst>
-          </a:prstGeom>
-          <a:solidFill>
-            <a:srgbClr val="EEF2F7"/>
-          </a:solidFill>
-          <a:ln w="12700">
-            <a:solidFill>
-              <a:srgbClr val="EEF2F7"/>
-            </a:solidFill>
-            <a:prstDash val="solid"/>
-          </a:ln>
-        </p:spPr>
-      </p:sp>
-      <p:sp>
-        <p:nvSpPr>
-          <p:cNvPr id="14" name="Text 12"/>
-          <p:cNvSpPr txBox="1"/>
-          <p:nvPr/>
-        </p:nvSpPr>
-        <p:spPr>
-          <a:xfrm>
-            <a:off x="4892040" y="1325880"/>
-            <a:ext cx="3566160" cy="228600"/>
-          </a:xfrm>
-          <a:prstGeom prst="rect">
-            <a:avLst/>
-          </a:prstGeom>
-          <a:noFill/>
-          <a:ln/>
-        </p:spPr>
-        <p:txBody>
-          <a:bodyPr wrap="square" lIns="0" tIns="0" rIns="0" bIns="0" rtlCol="0" anchor="ctr"/>
-          <a:lstStyle/>
-          <a:p>
-            <a:pPr indent="0" marL="0">
-              <a:buNone/>
-            </a:pPr>
-            <a:r>
-              <a:rPr lang="en-US" sz="950" b="1" spc="200" kern="0" dirty="0">
-                <a:solidFill>
-                  <a:srgbClr val="A65F00"/>
-                </a:solidFill>
-              </a:rPr>
-              <a:t>MODEL B — CLASSIFICATION</a:t>
-            </a:r>
-            <a:endParaRPr lang="en-US" sz="950" dirty="0"/>
-          </a:p>
-        </p:txBody>
-      </p:sp>
-      <p:sp>
-        <p:nvSpPr>
-          <p:cNvPr id="15" name="Text 13"/>
-          <p:cNvSpPr txBox="1"/>
-          <p:nvPr/>
-        </p:nvSpPr>
-        <p:spPr>
-          <a:xfrm>
-            <a:off x="4892040" y="1572768"/>
-            <a:ext cx="3566160" cy="365760"/>
-          </a:xfrm>
-          <a:prstGeom prst="rect">
-            <a:avLst/>
-          </a:prstGeom>
-          <a:noFill/>
-          <a:ln/>
-        </p:spPr>
-        <p:txBody>
-          <a:bodyPr wrap="square" lIns="0" tIns="0" rIns="0" bIns="0" rtlCol="0" anchor="ctr"/>
-          <a:lstStyle/>
-          <a:p>
-            <a:pPr indent="0" marL="0">
-              <a:buNone/>
-            </a:pPr>
-            <a:r>
-              <a:rPr lang="en-US" sz="1700" b="1" dirty="0">
-                <a:solidFill>
-                  <a:srgbClr val="14213D"/>
-                </a:solidFill>
-                <a:latin typeface="Cambria" pitchFamily="34" charset="0"/>
-                <a:ea typeface="Cambria" pitchFamily="34" charset="-122"/>
-                <a:cs typeface="Cambria" pitchFamily="34" charset="-120"/>
-              </a:rPr>
-              <a:t>Zone demand level → surge</a:t>
-            </a:r>
-            <a:endParaRPr lang="en-US" sz="1700" dirty="0"/>
-          </a:p>
-        </p:txBody>
-      </p:sp>
-      <p:sp>
-        <p:nvSpPr>
-          <p:cNvPr id="16" name="Text 14"/>
-          <p:cNvSpPr txBox="1"/>
-          <p:nvPr/>
-        </p:nvSpPr>
-        <p:spPr>
-          <a:xfrm>
-            <a:off x="4892040" y="1938528"/>
-            <a:ext cx="3566160" cy="256032"/>
-          </a:xfrm>
-          <a:prstGeom prst="rect">
-            <a:avLst/>
-          </a:prstGeom>
-          <a:noFill/>
-          <a:ln/>
-        </p:spPr>
-        <p:txBody>
-          <a:bodyPr wrap="square" lIns="0" tIns="0" rIns="0" bIns="0" rtlCol="0" anchor="ctr"/>
-          <a:lstStyle/>
-          <a:p>
-            <a:pPr indent="0" marL="0">
-              <a:buNone/>
-            </a:pPr>
-            <a:r>
-              <a:rPr lang="en-US" sz="1100" i="1" dirty="0">
-                <a:solidFill>
-                  <a:srgbClr val="5B6577"/>
-                </a:solidFill>
-              </a:rPr>
-              <a:t>Random Forest classifier · Low / Medium / High</a:t>
-            </a:r>
-            <a:endParaRPr lang="en-US" sz="1100" dirty="0"/>
-          </a:p>
-        </p:txBody>
-      </p:sp>
-      <p:sp>
-        <p:nvSpPr>
-          <p:cNvPr id="17" name="Text 15"/>
-          <p:cNvSpPr txBox="1"/>
-          <p:nvPr/>
-        </p:nvSpPr>
-        <p:spPr>
-          <a:xfrm>
-            <a:off x="4892040" y="2258568"/>
-            <a:ext cx="3611880" cy="1188720"/>
-          </a:xfrm>
-          <a:prstGeom prst="rect">
-            <a:avLst/>
-          </a:prstGeom>
-          <a:noFill/>
-          <a:ln/>
-        </p:spPr>
-        <p:txBody>
-          <a:bodyPr wrap="square" lIns="0" tIns="0" rIns="0" bIns="0" rtlCol="0" anchor="t"/>
-          <a:lstStyle/>
-          <a:p>
-            <a:pPr marL="342900" indent="-342900">
-              <a:spcAft>
-                <a:spcPts val="600"/>
-              </a:spcAft>
-              <a:buSzPct val="100000"/>
-              <a:buChar char="•"/>
-            </a:pPr>
-            <a:r>
-              <a:rPr lang="en-US" sz="1150" dirty="0">
-                <a:solidFill>
-                  <a:srgbClr val="1B2433"/>
-                </a:solidFill>
-                <a:latin typeface="Calibri" pitchFamily="34" charset="0"/>
-                <a:ea typeface="Calibri" pitchFamily="34" charset="-122"/>
-                <a:cs typeface="Calibri" pitchFamily="34" charset="-120"/>
-              </a:rPr>
-              <a:t>Trained on 38,158 MapReduce Job 4 cells</a:t>
-            </a:r>
-            <a:endParaRPr lang="en-US" sz="1150" dirty="0"/>
-          </a:p>
-          <a:p>
-            <a:pPr marL="342900" indent="-342900">
-              <a:spcAft>
-                <a:spcPts val="600"/>
-              </a:spcAft>
-              <a:buSzPct val="100000"/>
-              <a:buChar char="•"/>
-            </a:pPr>
-            <a:r>
-              <a:rPr lang="en-US" sz="1150" dirty="0">
-                <a:solidFill>
-                  <a:srgbClr val="1B2433"/>
-                </a:solidFill>
-                <a:latin typeface="Calibri" pitchFamily="34" charset="0"/>
-                <a:ea typeface="Calibri" pitchFamily="34" charset="-122"/>
-                <a:cs typeface="Calibri" pitchFamily="34" charset="-120"/>
-              </a:rPr>
-              <a:t>Features: hour, day, weekend, peak, zone, rain</a:t>
-            </a:r>
-            <a:endParaRPr lang="en-US" sz="1150" dirty="0"/>
-          </a:p>
-          <a:p>
-            <a:pPr marL="342900" indent="-342900">
-              <a:spcAft>
-                <a:spcPts val="600"/>
-              </a:spcAft>
-              <a:buSzPct val="100000"/>
-              <a:buChar char="•"/>
-            </a:pPr>
-            <a:r>
-              <a:rPr lang="en-US" sz="1150" dirty="0">
-                <a:solidFill>
-                  <a:srgbClr val="1B2433"/>
-                </a:solidFill>
-                <a:latin typeface="Calibri" pitchFamily="34" charset="0"/>
-                <a:ea typeface="Calibri" pitchFamily="34" charset="-122"/>
-                <a:cs typeface="Calibri" pitchFamily="34" charset="-120"/>
-              </a:rPr>
-              <a:t>Tertile labels: Low ≤ 4, Medium ≤ 8, High &gt; 8 trips / hour</a:t>
-            </a:r>
-            <a:endParaRPr lang="en-US" sz="1150" dirty="0"/>
-          </a:p>
-        </p:txBody>
-      </p:sp>
-      <p:sp>
-        <p:nvSpPr>
-          <p:cNvPr id="18" name="Text 16"/>
-          <p:cNvSpPr txBox="1"/>
-          <p:nvPr/>
-        </p:nvSpPr>
-        <p:spPr>
-          <a:xfrm>
-            <a:off x="4800600" y="3566160"/>
-            <a:ext cx="1828800" cy="457200"/>
-          </a:xfrm>
-          <a:prstGeom prst="rect">
-            <a:avLst/>
-          </a:prstGeom>
-          <a:noFill/>
-          <a:ln/>
-        </p:spPr>
-        <p:txBody>
-          <a:bodyPr wrap="square" lIns="0" tIns="0" rIns="0" bIns="0" rtlCol="0" anchor="ctr"/>
-          <a:lstStyle/>
-          <a:p>
-            <a:pPr algn="ctr" indent="0" marL="0">
-              <a:buNone/>
-            </a:pPr>
-            <a:r>
-              <a:rPr lang="en-US" sz="2200" b="1" dirty="0">
-                <a:solidFill>
-                  <a:srgbClr val="1B2433"/>
-                </a:solidFill>
-                <a:latin typeface="Cambria" pitchFamily="34" charset="0"/>
-                <a:ea typeface="Cambria" pitchFamily="34" charset="-122"/>
-                <a:cs typeface="Cambria" pitchFamily="34" charset="-120"/>
-              </a:rPr>
-              <a:t>68.0%</a:t>
-            </a:r>
-            <a:endParaRPr lang="en-US" sz="2200" dirty="0"/>
-          </a:p>
-        </p:txBody>
-      </p:sp>
-      <p:sp>
-        <p:nvSpPr>
-          <p:cNvPr id="19" name="Text 17"/>
-          <p:cNvSpPr txBox="1"/>
-          <p:nvPr/>
-        </p:nvSpPr>
-        <p:spPr>
-          <a:xfrm>
-            <a:off x="4800600" y="4023360"/>
-            <a:ext cx="1828800" cy="274320"/>
-          </a:xfrm>
-          <a:prstGeom prst="rect">
-            <a:avLst/>
-          </a:prstGeom>
-          <a:noFill/>
-          <a:ln/>
-        </p:spPr>
-        <p:txBody>
-          <a:bodyPr wrap="square" lIns="0" tIns="0" rIns="0" bIns="0" rtlCol="0" anchor="ctr"/>
-          <a:lstStyle/>
-          <a:p>
-            <a:pPr algn="ctr" indent="0" marL="0">
-              <a:buNone/>
-            </a:pPr>
-            <a:r>
-              <a:rPr lang="en-US" sz="1050" dirty="0">
-                <a:solidFill>
-                  <a:srgbClr val="5B6577"/>
-                </a:solidFill>
-              </a:rPr>
-              <a:t>Accuracy (random = 33%)</a:t>
-            </a:r>
-            <a:endParaRPr lang="en-US" sz="1050" dirty="0"/>
-          </a:p>
-        </p:txBody>
-      </p:sp>
-      <p:sp>
-        <p:nvSpPr>
-          <p:cNvPr id="20" name="Text 18"/>
-          <p:cNvSpPr txBox="1"/>
-          <p:nvPr/>
-        </p:nvSpPr>
-        <p:spPr>
-          <a:xfrm>
-            <a:off x="6675120" y="3566160"/>
-            <a:ext cx="1828800" cy="457200"/>
-          </a:xfrm>
-          <a:prstGeom prst="rect">
-            <a:avLst/>
-          </a:prstGeom>
-          <a:noFill/>
-          <a:ln/>
-        </p:spPr>
-        <p:txBody>
-          <a:bodyPr wrap="square" lIns="0" tIns="0" rIns="0" bIns="0" rtlCol="0" anchor="ctr"/>
-          <a:lstStyle/>
-          <a:p>
-            <a:pPr algn="ctr" indent="0" marL="0">
-              <a:buNone/>
-            </a:pPr>
-            <a:r>
-              <a:rPr lang="en-US" sz="2200" b="1" dirty="0">
-                <a:solidFill>
-                  <a:srgbClr val="1B2433"/>
-                </a:solidFill>
-                <a:latin typeface="Cambria" pitchFamily="34" charset="0"/>
-                <a:ea typeface="Cambria" pitchFamily="34" charset="-122"/>
-                <a:cs typeface="Cambria" pitchFamily="34" charset="-120"/>
-              </a:rPr>
-              <a:t>0.687</a:t>
-            </a:r>
-            <a:endParaRPr lang="en-US" sz="2200" dirty="0"/>
-          </a:p>
-        </p:txBody>
-      </p:sp>
-      <p:sp>
-        <p:nvSpPr>
-          <p:cNvPr id="21" name="Text 19"/>
-          <p:cNvSpPr txBox="1"/>
-          <p:nvPr/>
-        </p:nvSpPr>
-        <p:spPr>
-          <a:xfrm>
-            <a:off x="6675120" y="4023360"/>
-            <a:ext cx="1828800" cy="274320"/>
-          </a:xfrm>
-          <a:prstGeom prst="rect">
-            <a:avLst/>
-          </a:prstGeom>
-          <a:noFill/>
-          <a:ln/>
-        </p:spPr>
-        <p:txBody>
-          <a:bodyPr wrap="square" lIns="0" tIns="0" rIns="0" bIns="0" rtlCol="0" anchor="ctr"/>
-          <a:lstStyle/>
-          <a:p>
-            <a:pPr algn="ctr" indent="0" marL="0">
-              <a:buNone/>
-            </a:pPr>
-            <a:r>
-              <a:rPr lang="en-US" sz="1050" dirty="0">
-                <a:solidFill>
-                  <a:srgbClr val="5B6577"/>
-                </a:solidFill>
-              </a:rPr>
-              <a:t>Weighted F1</a:t>
-            </a:r>
-            <a:endParaRPr lang="en-US" sz="1050" dirty="0"/>
-          </a:p>
-        </p:txBody>
-      </p:sp>
-      <p:sp>
-        <p:nvSpPr>
-          <p:cNvPr id="25" name="Slide Number Placeholder 0"/>
-          <p:cNvSpPr>
-            <a:spLocks noGrp="1"/>
-          </p:cNvSpPr>
-          <p:nvPr>
-            <p:ph type="sldNum" sz="quarter" idx="4294967295"/>
-          </p:nvPr>
-        </p:nvSpPr>
-        <p:spPr>
-          <a:xfrm>
-            <a:off x="8229600" y="4754880"/>
-            <a:ext cx="457200" cy="274320"/>
-          </a:xfrm>
-          <a:prstGeom prst="rect">
-            <a:avLst/>
-          </a:prstGeom>
-          <a:extLst>
-            <a:ext uri="{C572A759-6A51-4108-AA02-DFA0A04FC94B}">
-              <ma14:wrappingTextBoxFlag xmlns:ma14="http://schemas.microsoft.com/office/mac/drawingml/2011/main" val="0"/>
-            </a:ext>
-          </a:extLst>
-        </p:spPr>
-        <p:txBody>
-          <a:bodyPr/>
-          <a:lstStyle>
-            <a:lvl1pPr>
-              <a:defRPr sz="900">
-                <a:solidFill>
-                  <a:srgbClr val="5B6577"/>
-                </a:solidFill>
-                <a:latin typeface="Calibri"/>
-                <a:ea typeface="Calibri"/>
-                <a:cs typeface="Calibri"/>
-              </a:defRPr>
-            </a:lvl1pPr>
-          </a:lstStyle>
-          <a:p>
-            <a:pPr algn="r"/>
-            <a:fld id="{F7021451-1387-4CA6-816F-3879F97B5CBC}" type="slidenum">
-              <a:rPr b="0" lang="en-US"/>
-              <a:t>9</a:t>
-            </a:fld>
-            <a:endParaRPr lang="en-US"/>
-          </a:p>
-        </p:txBody>
-      </p:sp>
-    </p:spTree>
-  </p:cSld>
-  <p:clrMapOvr>
-    <a:masterClrMapping/>
-  </p:clrMapOvr>
-</p:sld>
-</file>
-
-<file path=ppt/slides/slide12.xml><?xml version="1.0" encoding="utf-8"?>
+<file path=ppt/slides/slide10.xml><?xml version="1.0" encoding="utf-8"?>
 <p:sld xmlns:a="http://schemas.openxmlformats.org/drawingml/2006/main" xmlns:r="http://schemas.openxmlformats.org/officeDocument/2006/relationships" xmlns:p="http://schemas.openxmlformats.org/presentationml/2006/main">
   <p:cSld name="Slide 12">
     <p:spTree>
@@ -5453,7 +4556,7 @@
 </p:sld>
 </file>
 
-<file path=ppt/slides/slide15.xml><?xml version="1.0" encoding="utf-8"?>
+<file path=ppt/slides/slide11.xml><?xml version="1.0" encoding="utf-8"?>
 <p:sld xmlns:a="http://schemas.openxmlformats.org/drawingml/2006/main" xmlns:r="http://schemas.openxmlformats.org/officeDocument/2006/relationships" xmlns:p="http://schemas.openxmlformats.org/presentationml/2006/main">
   <p:cSld name="Slide 15">
     <p:spTree>
@@ -6284,7 +5387,7 @@
 </p:sld>
 </file>
 
-<file path=ppt/slides/slide17.xml><?xml version="1.0" encoding="utf-8"?>
+<file path=ppt/slides/slide12.xml><?xml version="1.0" encoding="utf-8"?>
 <p:sld xmlns:a="http://schemas.openxmlformats.org/drawingml/2006/main" xmlns:r="http://schemas.openxmlformats.org/officeDocument/2006/relationships" xmlns:p="http://schemas.openxmlformats.org/presentationml/2006/main">
   <p:cSld name="Slide 17">
     <p:spTree>
@@ -6334,7 +5437,7 @@
         </p:nvSpPr>
         <p:spPr>
           <a:xfrm>
-            <a:off x="594360" y="822960"/>
+            <a:off x="594360" y="1554480"/>
             <a:ext cx="7315200" cy="731520"/>
           </a:xfrm>
           <a:prstGeom prst="rect">
@@ -6367,484 +5470,71 @@
       </p:sp>
       <p:sp>
         <p:nvSpPr>
-          <p:cNvPr id="4" name="Text 2"/>
-          <p:cNvSpPr txBox="1"/>
-          <p:nvPr/>
-        </p:nvSpPr>
-        <p:spPr>
-          <a:xfrm>
-            <a:off x="594360" y="1600200"/>
-            <a:ext cx="7680960" cy="640080"/>
-          </a:xfrm>
-          <a:prstGeom prst="rect">
-            <a:avLst/>
-          </a:prstGeom>
-          <a:noFill/>
-          <a:ln/>
-        </p:spPr>
-        <p:txBody>
-          <a:bodyPr wrap="square" lIns="0" tIns="0" rIns="0" bIns="0" rtlCol="0" anchor="ctr"/>
-          <a:lstStyle/>
-          <a:p>
-            <a:pPr indent="0" marL="0">
-              <a:buNone/>
-            </a:pPr>
-            <a:r>
-              <a:rPr lang="en-US" sz="1400" dirty="0">
+          <p:cNvPr id="4" name="TextBox 3"/>
+          <p:cNvSpPr txBox="1"/>
+          <p:nvPr/>
+        </p:nvSpPr>
+        <p:spPr>
+          <a:xfrm>
+            <a:off x="594360" y="2423160"/>
+            <a:ext cx="7680960" cy="320040"/>
+          </a:xfrm>
+          <a:prstGeom prst="rect">
+            <a:avLst/>
+          </a:prstGeom>
+          <a:noFill/>
+        </p:spPr>
+        <p:txBody>
+          <a:bodyPr wrap="none" lIns="0" rIns="0" tIns="0" bIns="0">
+            <a:spAutoFit/>
+          </a:bodyPr>
+          <a:lstStyle/>
+          <a:p>
+            <a:r>
+              <a:rPr sz="1200" b="1">
                 <a:solidFill>
                   <a:srgbClr val="C9D3E3"/>
                 </a:solidFill>
               </a:rPr>
-              <a:t>A complete Big Data pipeline — generation, cleaning, MapReduce, analytics and machine learning — processing 247,951 Bengaluru trips end-to-end in about 10 seconds.</a:t>
-            </a:r>
-            <a:endParaRPr lang="en-US" sz="1400" dirty="0"/>
-          </a:p>
-        </p:txBody>
-      </p:sp>
-      <p:sp>
-        <p:nvSpPr>
-          <p:cNvPr id="5" name="Shape 3"/>
-          <p:cNvSpPr/>
-          <p:nvPr/>
-        </p:nvSpPr>
-        <p:spPr>
-          <a:xfrm>
-            <a:off x="594360" y="2514600"/>
-            <a:ext cx="1828800" cy="914400"/>
-          </a:xfrm>
-          <a:prstGeom prst="roundRect">
-            <a:avLst>
-              <a:gd name="adj" fmla="val 8000"/>
-            </a:avLst>
-          </a:prstGeom>
-          <a:solidFill>
-            <a:srgbClr val="233554"/>
-          </a:solidFill>
-          <a:ln w="12700">
-            <a:solidFill>
-              <a:srgbClr val="233554"/>
-            </a:solidFill>
-            <a:prstDash val="solid"/>
-          </a:ln>
-        </p:spPr>
-      </p:sp>
-      <p:sp>
-        <p:nvSpPr>
-          <p:cNvPr id="6" name="Text 4"/>
-          <p:cNvSpPr txBox="1"/>
-          <p:nvPr/>
-        </p:nvSpPr>
-        <p:spPr>
-          <a:xfrm>
-            <a:off x="594360" y="2578608"/>
-            <a:ext cx="1828800" cy="457200"/>
-          </a:xfrm>
-          <a:prstGeom prst="rect">
-            <a:avLst/>
-          </a:prstGeom>
-          <a:noFill/>
-          <a:ln/>
-        </p:spPr>
-        <p:txBody>
-          <a:bodyPr wrap="square" lIns="0" tIns="0" rIns="0" bIns="0" rtlCol="0" anchor="ctr"/>
-          <a:lstStyle/>
-          <a:p>
-            <a:pPr algn="ctr" indent="0" marL="0">
-              <a:buNone/>
-            </a:pPr>
-            <a:r>
-              <a:rPr lang="en-US" sz="2400" b="1" dirty="0">
+              <a:t>GITHUB REPOSITORY</a:t>
+            </a:r>
+          </a:p>
+        </p:txBody>
+      </p:sp>
+      <p:sp>
+        <p:nvSpPr>
+          <p:cNvPr id="5" name="TextBox 4">
+            <a:hlinkClick r:id="rId3"/>
+          </p:cNvPr>
+          <p:cNvSpPr txBox="1"/>
+          <p:nvPr/>
+        </p:nvSpPr>
+        <p:spPr>
+          <a:xfrm>
+            <a:off x="594360" y="2743200"/>
+            <a:ext cx="7955280" cy="457200"/>
+          </a:xfrm>
+          <a:prstGeom prst="rect">
+            <a:avLst/>
+          </a:prstGeom>
+          <a:noFill/>
+        </p:spPr>
+        <p:txBody>
+          <a:bodyPr wrap="square" lIns="0" rIns="0" tIns="0" bIns="0">
+            <a:spAutoFit/>
+          </a:bodyPr>
+          <a:lstStyle/>
+          <a:p>
+            <a:pPr algn="l"/>
+            <a:r>
+              <a:rPr sz="1700" b="1" u="sng">
                 <a:solidFill>
                   <a:srgbClr val="F5A623"/>
                 </a:solidFill>
-                <a:latin typeface="Cambria" pitchFamily="34" charset="0"/>
-                <a:ea typeface="Cambria" pitchFamily="34" charset="-122"/>
-                <a:cs typeface="Cambria" pitchFamily="34" charset="-120"/>
-              </a:rPr>
-              <a:t>4</a:t>
-            </a:r>
-            <a:endParaRPr lang="en-US" sz="2400" dirty="0"/>
-          </a:p>
-        </p:txBody>
-      </p:sp>
-      <p:sp>
-        <p:nvSpPr>
-          <p:cNvPr id="7" name="Text 5"/>
-          <p:cNvSpPr txBox="1"/>
-          <p:nvPr/>
-        </p:nvSpPr>
-        <p:spPr>
-          <a:xfrm>
-            <a:off x="594360" y="3035808"/>
-            <a:ext cx="1828800" cy="274320"/>
-          </a:xfrm>
-          <a:prstGeom prst="rect">
-            <a:avLst/>
-          </a:prstGeom>
-          <a:noFill/>
-          <a:ln/>
-        </p:spPr>
-        <p:txBody>
-          <a:bodyPr wrap="square" lIns="0" tIns="0" rIns="0" bIns="0" rtlCol="0" anchor="ctr"/>
-          <a:lstStyle/>
-          <a:p>
-            <a:pPr algn="ctr" indent="0" marL="0">
-              <a:buNone/>
-            </a:pPr>
-            <a:r>
-              <a:rPr lang="en-US" sz="1100" dirty="0">
-                <a:solidFill>
-                  <a:srgbClr val="C9D3E3"/>
-                </a:solidFill>
-              </a:rPr>
-              <a:t>MapReduce jobs</a:t>
-            </a:r>
-            <a:endParaRPr lang="en-US" sz="1100" dirty="0"/>
-          </a:p>
-        </p:txBody>
-      </p:sp>
-      <p:sp>
-        <p:nvSpPr>
-          <p:cNvPr id="8" name="Shape 6"/>
-          <p:cNvSpPr/>
-          <p:nvPr/>
-        </p:nvSpPr>
-        <p:spPr>
-          <a:xfrm>
-            <a:off x="2587752" y="2514600"/>
-            <a:ext cx="1828800" cy="914400"/>
-          </a:xfrm>
-          <a:prstGeom prst="roundRect">
-            <a:avLst>
-              <a:gd name="adj" fmla="val 8000"/>
-            </a:avLst>
-          </a:prstGeom>
-          <a:solidFill>
-            <a:srgbClr val="233554"/>
-          </a:solidFill>
-          <a:ln w="12700">
-            <a:solidFill>
-              <a:srgbClr val="233554"/>
-            </a:solidFill>
-            <a:prstDash val="solid"/>
-          </a:ln>
-        </p:spPr>
-      </p:sp>
-      <p:sp>
-        <p:nvSpPr>
-          <p:cNvPr id="9" name="Text 7"/>
-          <p:cNvSpPr txBox="1"/>
-          <p:nvPr/>
-        </p:nvSpPr>
-        <p:spPr>
-          <a:xfrm>
-            <a:off x="2587752" y="2578608"/>
-            <a:ext cx="1828800" cy="457200"/>
-          </a:xfrm>
-          <a:prstGeom prst="rect">
-            <a:avLst/>
-          </a:prstGeom>
-          <a:noFill/>
-          <a:ln/>
-        </p:spPr>
-        <p:txBody>
-          <a:bodyPr wrap="square" lIns="0" tIns="0" rIns="0" bIns="0" rtlCol="0" anchor="ctr"/>
-          <a:lstStyle/>
-          <a:p>
-            <a:pPr algn="ctr" indent="0" marL="0">
-              <a:buNone/>
-            </a:pPr>
-            <a:r>
-              <a:rPr lang="en-US" sz="2400" b="1" dirty="0">
-                <a:solidFill>
-                  <a:srgbClr val="F5A623"/>
-                </a:solidFill>
-                <a:latin typeface="Cambria" pitchFamily="34" charset="0"/>
-                <a:ea typeface="Cambria" pitchFamily="34" charset="-122"/>
-                <a:cs typeface="Cambria" pitchFamily="34" charset="-120"/>
-              </a:rPr>
-              <a:t>20+</a:t>
-            </a:r>
-            <a:endParaRPr lang="en-US" sz="2400" dirty="0"/>
-          </a:p>
-        </p:txBody>
-      </p:sp>
-      <p:sp>
-        <p:nvSpPr>
-          <p:cNvPr id="10" name="Text 8"/>
-          <p:cNvSpPr txBox="1"/>
-          <p:nvPr/>
-        </p:nvSpPr>
-        <p:spPr>
-          <a:xfrm>
-            <a:off x="2587752" y="3035808"/>
-            <a:ext cx="1828800" cy="274320"/>
-          </a:xfrm>
-          <a:prstGeom prst="rect">
-            <a:avLst/>
-          </a:prstGeom>
-          <a:noFill/>
-          <a:ln/>
-        </p:spPr>
-        <p:txBody>
-          <a:bodyPr wrap="square" lIns="0" tIns="0" rIns="0" bIns="0" rtlCol="0" anchor="ctr"/>
-          <a:lstStyle/>
-          <a:p>
-            <a:pPr algn="ctr" indent="0" marL="0">
-              <a:buNone/>
-            </a:pPr>
-            <a:r>
-              <a:rPr lang="en-US" sz="1100" dirty="0">
-                <a:solidFill>
-                  <a:srgbClr val="C9D3E3"/>
-                </a:solidFill>
-              </a:rPr>
-              <a:t>Charts &amp; tables</a:t>
-            </a:r>
-            <a:endParaRPr lang="en-US" sz="1100" dirty="0"/>
-          </a:p>
-        </p:txBody>
-      </p:sp>
-      <p:sp>
-        <p:nvSpPr>
-          <p:cNvPr id="11" name="Shape 9"/>
-          <p:cNvSpPr/>
-          <p:nvPr/>
-        </p:nvSpPr>
-        <p:spPr>
-          <a:xfrm>
-            <a:off x="4581144" y="2514600"/>
-            <a:ext cx="1828800" cy="914400"/>
-          </a:xfrm>
-          <a:prstGeom prst="roundRect">
-            <a:avLst>
-              <a:gd name="adj" fmla="val 8000"/>
-            </a:avLst>
-          </a:prstGeom>
-          <a:solidFill>
-            <a:srgbClr val="233554"/>
-          </a:solidFill>
-          <a:ln w="12700">
-            <a:solidFill>
-              <a:srgbClr val="233554"/>
-            </a:solidFill>
-            <a:prstDash val="solid"/>
-          </a:ln>
-        </p:spPr>
-      </p:sp>
-      <p:sp>
-        <p:nvSpPr>
-          <p:cNvPr id="12" name="Text 10"/>
-          <p:cNvSpPr txBox="1"/>
-          <p:nvPr/>
-        </p:nvSpPr>
-        <p:spPr>
-          <a:xfrm>
-            <a:off x="4581144" y="2578608"/>
-            <a:ext cx="1828800" cy="457200"/>
-          </a:xfrm>
-          <a:prstGeom prst="rect">
-            <a:avLst/>
-          </a:prstGeom>
-          <a:noFill/>
-          <a:ln/>
-        </p:spPr>
-        <p:txBody>
-          <a:bodyPr wrap="square" lIns="0" tIns="0" rIns="0" bIns="0" rtlCol="0" anchor="ctr"/>
-          <a:lstStyle/>
-          <a:p>
-            <a:pPr algn="ctr" indent="0" marL="0">
-              <a:buNone/>
-            </a:pPr>
-            <a:r>
-              <a:rPr lang="en-US" sz="2400" b="1" dirty="0">
-                <a:solidFill>
-                  <a:srgbClr val="F5A623"/>
-                </a:solidFill>
-                <a:latin typeface="Cambria" pitchFamily="34" charset="0"/>
-                <a:ea typeface="Cambria" pitchFamily="34" charset="-122"/>
-                <a:cs typeface="Cambria" pitchFamily="34" charset="-120"/>
-              </a:rPr>
-              <a:t>2</a:t>
-            </a:r>
-            <a:endParaRPr lang="en-US" sz="2400" dirty="0"/>
-          </a:p>
-        </p:txBody>
-      </p:sp>
-      <p:sp>
-        <p:nvSpPr>
-          <p:cNvPr id="13" name="Text 11"/>
-          <p:cNvSpPr txBox="1"/>
-          <p:nvPr/>
-        </p:nvSpPr>
-        <p:spPr>
-          <a:xfrm>
-            <a:off x="4581144" y="3035808"/>
-            <a:ext cx="1828800" cy="274320"/>
-          </a:xfrm>
-          <a:prstGeom prst="rect">
-            <a:avLst/>
-          </a:prstGeom>
-          <a:noFill/>
-          <a:ln/>
-        </p:spPr>
-        <p:txBody>
-          <a:bodyPr wrap="square" lIns="0" tIns="0" rIns="0" bIns="0" rtlCol="0" anchor="ctr"/>
-          <a:lstStyle/>
-          <a:p>
-            <a:pPr algn="ctr" indent="0" marL="0">
-              <a:buNone/>
-            </a:pPr>
-            <a:r>
-              <a:rPr lang="en-US" sz="1100" dirty="0">
-                <a:solidFill>
-                  <a:srgbClr val="C9D3E3"/>
-                </a:solidFill>
-              </a:rPr>
-              <a:t>ML models</a:t>
-            </a:r>
-            <a:endParaRPr lang="en-US" sz="1100" dirty="0"/>
-          </a:p>
-        </p:txBody>
-      </p:sp>
-      <p:sp>
-        <p:nvSpPr>
-          <p:cNvPr id="14" name="Shape 12"/>
-          <p:cNvSpPr/>
-          <p:nvPr/>
-        </p:nvSpPr>
-        <p:spPr>
-          <a:xfrm>
-            <a:off x="6574536" y="2514600"/>
-            <a:ext cx="1828800" cy="914400"/>
-          </a:xfrm>
-          <a:prstGeom prst="roundRect">
-            <a:avLst>
-              <a:gd name="adj" fmla="val 8000"/>
-            </a:avLst>
-          </a:prstGeom>
-          <a:solidFill>
-            <a:srgbClr val="233554"/>
-          </a:solidFill>
-          <a:ln w="12700">
-            <a:solidFill>
-              <a:srgbClr val="233554"/>
-            </a:solidFill>
-            <a:prstDash val="solid"/>
-          </a:ln>
-        </p:spPr>
-      </p:sp>
-      <p:sp>
-        <p:nvSpPr>
-          <p:cNvPr id="15" name="Text 13"/>
-          <p:cNvSpPr txBox="1"/>
-          <p:nvPr/>
-        </p:nvSpPr>
-        <p:spPr>
-          <a:xfrm>
-            <a:off x="6574536" y="2578608"/>
-            <a:ext cx="1828800" cy="457200"/>
-          </a:xfrm>
-          <a:prstGeom prst="rect">
-            <a:avLst/>
-          </a:prstGeom>
-          <a:noFill/>
-          <a:ln/>
-        </p:spPr>
-        <p:txBody>
-          <a:bodyPr wrap="square" lIns="0" tIns="0" rIns="0" bIns="0" rtlCol="0" anchor="ctr"/>
-          <a:lstStyle/>
-          <a:p>
-            <a:pPr algn="ctr" indent="0" marL="0">
-              <a:buNone/>
-            </a:pPr>
-            <a:r>
-              <a:rPr lang="en-US" sz="2400" b="1" dirty="0">
-                <a:solidFill>
-                  <a:srgbClr val="F5A623"/>
-                </a:solidFill>
-                <a:latin typeface="Cambria" pitchFamily="34" charset="0"/>
-                <a:ea typeface="Cambria" pitchFamily="34" charset="-122"/>
-                <a:cs typeface="Cambria" pitchFamily="34" charset="-120"/>
-              </a:rPr>
-              <a:t>3</a:t>
-            </a:r>
-            <a:endParaRPr lang="en-US" sz="2400" dirty="0"/>
-          </a:p>
-        </p:txBody>
-      </p:sp>
-      <p:sp>
-        <p:nvSpPr>
-          <p:cNvPr id="16" name="Text 14"/>
-          <p:cNvSpPr txBox="1"/>
-          <p:nvPr/>
-        </p:nvSpPr>
-        <p:spPr>
-          <a:xfrm>
-            <a:off x="6574536" y="3035808"/>
-            <a:ext cx="1828800" cy="274320"/>
-          </a:xfrm>
-          <a:prstGeom prst="rect">
-            <a:avLst/>
-          </a:prstGeom>
-          <a:noFill/>
-          <a:ln/>
-        </p:spPr>
-        <p:txBody>
-          <a:bodyPr wrap="square" lIns="0" tIns="0" rIns="0" bIns="0" rtlCol="0" anchor="ctr"/>
-          <a:lstStyle/>
-          <a:p>
-            <a:pPr algn="ctr" indent="0" marL="0">
-              <a:buNone/>
-            </a:pPr>
-            <a:r>
-              <a:rPr lang="en-US" sz="1100" dirty="0">
-                <a:solidFill>
-                  <a:srgbClr val="C9D3E3"/>
-                </a:solidFill>
-              </a:rPr>
-              <a:t>Role views</a:t>
-            </a:r>
-            <a:endParaRPr lang="en-US" sz="1100" dirty="0"/>
-          </a:p>
-        </p:txBody>
-      </p:sp>
-      <p:sp>
-        <p:nvSpPr>
-          <p:cNvPr id="17" name="Text 15"/>
-          <p:cNvSpPr txBox="1"/>
-          <p:nvPr/>
-        </p:nvSpPr>
-        <p:spPr>
-          <a:xfrm>
-            <a:off x="594360" y="3931920"/>
-            <a:ext cx="7315200" cy="457200"/>
-          </a:xfrm>
-          <a:prstGeom prst="rect">
-            <a:avLst/>
-          </a:prstGeom>
-          <a:noFill/>
-          <a:ln/>
-        </p:spPr>
-        <p:txBody>
-          <a:bodyPr wrap="square" lIns="0" tIns="0" rIns="0" bIns="0" rtlCol="0" anchor="ctr"/>
-          <a:lstStyle/>
-          <a:p>
-            <a:pPr indent="0" marL="0">
-              <a:buNone/>
-            </a:pPr>
-            <a:r>
-              <a:rPr lang="en-US" sz="2200" b="1" dirty="0">
-                <a:solidFill>
-                  <a:srgbClr val="F5A623"/>
-                </a:solidFill>
-                <a:latin typeface="Cambria" pitchFamily="34" charset="0"/>
-                <a:ea typeface="Cambria" pitchFamily="34" charset="-122"/>
-                <a:cs typeface="Cambria" pitchFamily="34" charset="-120"/>
-              </a:rPr>
-              <a:t>Questions?</a:t>
-            </a:r>
-            <a:endParaRPr lang="en-US" sz="2200" dirty="0"/>
+                <a:latin typeface="Cambria"/>
+              </a:rPr>
+              <a:t>https://github.com/AnoonMR/bengaluru-urban-mobility-analytics</a:t>
+            </a:r>
           </a:p>
         </p:txBody>
       </p:sp>
@@ -9975,7 +8665,7 @@
 </p:sld>
 </file>
 
-<file path=ppt/slides/slide6.xml><?xml version="1.0" encoding="utf-8"?>
+<file path=ppt/slides/slide5.xml><?xml version="1.0" encoding="utf-8"?>
 <p:sld xmlns:a="http://schemas.openxmlformats.org/drawingml/2006/main" xmlns:r="http://schemas.openxmlformats.org/officeDocument/2006/relationships" xmlns:p="http://schemas.openxmlformats.org/presentationml/2006/main">
   <p:cSld name="Slide 6">
     <p:spTree>
@@ -10802,7 +9492,7 @@
 </p:sld>
 </file>
 
-<file path=ppt/slides/slide7.xml><?xml version="1.0" encoding="utf-8"?>
+<file path=ppt/slides/slide6.xml><?xml version="1.0" encoding="utf-8"?>
 <p:sld xmlns:a="http://schemas.openxmlformats.org/drawingml/2006/main" xmlns:r="http://schemas.openxmlformats.org/officeDocument/2006/relationships" xmlns:p="http://schemas.openxmlformats.org/presentationml/2006/main">
   <p:cSld name="Slide 7">
     <p:spTree>
@@ -11102,7 +9792,7 @@
 </p:sld>
 </file>
 
-<file path=ppt/slides/slide8.xml><?xml version="1.0" encoding="utf-8"?>
+<file path=ppt/slides/slide7.xml><?xml version="1.0" encoding="utf-8"?>
 <p:sld xmlns:a="http://schemas.openxmlformats.org/drawingml/2006/main" xmlns:r="http://schemas.openxmlformats.org/officeDocument/2006/relationships" xmlns:p="http://schemas.openxmlformats.org/presentationml/2006/main">
   <p:cSld name="Slide 8">
     <p:spTree>
@@ -12760,7 +11450,7 @@
 </p:sld>
 </file>
 
-<file path=ppt/slides/slide9.xml><?xml version="1.0" encoding="utf-8"?>
+<file path=ppt/slides/slide8.xml><?xml version="1.0" encoding="utf-8"?>
 <p:sld xmlns:a="http://schemas.openxmlformats.org/drawingml/2006/main" xmlns:r="http://schemas.openxmlformats.org/officeDocument/2006/relationships" xmlns:p="http://schemas.openxmlformats.org/presentationml/2006/main">
   <p:cSld name="Slide 9">
     <p:spTree>
@@ -14071,6 +12761,903 @@
             <a:fld id="{F7021451-1387-4CA6-816F-3879F97B5CBC}" type="slidenum">
               <a:rPr b="0" lang="en-US"/>
               <a:t>8</a:t>
+            </a:fld>
+            <a:endParaRPr lang="en-US"/>
+          </a:p>
+        </p:txBody>
+      </p:sp>
+    </p:spTree>
+  </p:cSld>
+  <p:clrMapOvr>
+    <a:masterClrMapping/>
+  </p:clrMapOvr>
+</p:sld>
+</file>
+
+<file path=ppt/slides/slide9.xml><?xml version="1.0" encoding="utf-8"?>
+<p:sld xmlns:a="http://schemas.openxmlformats.org/drawingml/2006/main" xmlns:r="http://schemas.openxmlformats.org/officeDocument/2006/relationships" xmlns:p="http://schemas.openxmlformats.org/presentationml/2006/main">
+  <p:cSld name="Slide 11">
+    <p:spTree>
+      <p:nvGrpSpPr>
+        <p:cNvPr id="1" name=""/>
+        <p:cNvGrpSpPr/>
+        <p:nvPr/>
+      </p:nvGrpSpPr>
+      <p:grpSpPr>
+        <a:xfrm>
+          <a:off x="0" y="0"/>
+          <a:ext cx="0" cy="0"/>
+          <a:chOff x="0" y="0"/>
+          <a:chExt cx="0" cy="0"/>
+        </a:xfrm>
+      </p:grpSpPr>
+      <p:sp>
+        <p:nvSpPr>
+          <p:cNvPr id="2" name="Text 0"/>
+          <p:cNvSpPr txBox="1"/>
+          <p:nvPr/>
+        </p:nvSpPr>
+        <p:spPr>
+          <a:xfrm>
+            <a:off x="457200" y="274320"/>
+            <a:ext cx="8229600" cy="274320"/>
+          </a:xfrm>
+          <a:prstGeom prst="rect">
+            <a:avLst/>
+          </a:prstGeom>
+          <a:noFill/>
+          <a:ln/>
+        </p:spPr>
+        <p:txBody>
+          <a:bodyPr wrap="square" lIns="0" tIns="0" rIns="0" bIns="0" rtlCol="0" anchor="ctr"/>
+          <a:lstStyle/>
+          <a:p>
+            <a:pPr indent="0" marL="0">
+              <a:buNone/>
+            </a:pPr>
+            <a:r>
+              <a:rPr lang="en-US" sz="1000" b="1" spc="300" kern="0" dirty="0">
+                <a:solidFill>
+                  <a:srgbClr val="A65F00"/>
+                </a:solidFill>
+                <a:latin typeface="Calibri" pitchFamily="34" charset="0"/>
+                <a:ea typeface="Calibri" pitchFamily="34" charset="-122"/>
+                <a:cs typeface="Calibri" pitchFamily="34" charset="-120"/>
+              </a:rPr>
+              <a:t>STAGE 4</a:t>
+            </a:r>
+            <a:endParaRPr lang="en-US" sz="1000" dirty="0"/>
+          </a:p>
+        </p:txBody>
+      </p:sp>
+      <p:sp>
+        <p:nvSpPr>
+          <p:cNvPr id="3" name="Text 1"/>
+          <p:cNvSpPr txBox="1"/>
+          <p:nvPr/>
+        </p:nvSpPr>
+        <p:spPr>
+          <a:xfrm>
+            <a:off x="457200" y="530352"/>
+            <a:ext cx="8229600" cy="548640"/>
+          </a:xfrm>
+          <a:prstGeom prst="rect">
+            <a:avLst/>
+          </a:prstGeom>
+          <a:noFill/>
+          <a:ln/>
+        </p:spPr>
+        <p:txBody>
+          <a:bodyPr wrap="square" lIns="0" tIns="0" rIns="0" bIns="0" rtlCol="0" anchor="ctr"/>
+          <a:lstStyle/>
+          <a:p>
+            <a:pPr indent="0" marL="0">
+              <a:buNone/>
+            </a:pPr>
+            <a:r>
+              <a:rPr lang="en-US" sz="2800" b="1" dirty="0">
+                <a:solidFill>
+                  <a:srgbClr val="14213D"/>
+                </a:solidFill>
+                <a:latin typeface="Cambria" pitchFamily="34" charset="0"/>
+                <a:ea typeface="Cambria" pitchFamily="34" charset="-122"/>
+                <a:cs typeface="Cambria" pitchFamily="34" charset="-120"/>
+              </a:rPr>
+              <a:t>Machine learning models</a:t>
+            </a:r>
+            <a:endParaRPr lang="en-US" sz="2800" dirty="0"/>
+          </a:p>
+        </p:txBody>
+      </p:sp>
+      <p:sp>
+        <p:nvSpPr>
+          <p:cNvPr id="4" name="Shape 2"/>
+          <p:cNvSpPr/>
+          <p:nvPr/>
+        </p:nvSpPr>
+        <p:spPr>
+          <a:xfrm>
+            <a:off x="457200" y="1188720"/>
+            <a:ext cx="4023360" cy="3337560"/>
+          </a:xfrm>
+          <a:prstGeom prst="roundRect">
+            <a:avLst>
+              <a:gd name="adj" fmla="val 2192"/>
+            </a:avLst>
+          </a:prstGeom>
+          <a:solidFill>
+            <a:srgbClr val="EEF2F7"/>
+          </a:solidFill>
+          <a:ln w="12700">
+            <a:solidFill>
+              <a:srgbClr val="EEF2F7"/>
+            </a:solidFill>
+            <a:prstDash val="solid"/>
+          </a:ln>
+        </p:spPr>
+      </p:sp>
+      <p:sp>
+        <p:nvSpPr>
+          <p:cNvPr id="5" name="Text 3"/>
+          <p:cNvSpPr txBox="1"/>
+          <p:nvPr/>
+        </p:nvSpPr>
+        <p:spPr>
+          <a:xfrm>
+            <a:off x="685800" y="1325880"/>
+            <a:ext cx="3566160" cy="228600"/>
+          </a:xfrm>
+          <a:prstGeom prst="rect">
+            <a:avLst/>
+          </a:prstGeom>
+          <a:noFill/>
+          <a:ln/>
+        </p:spPr>
+        <p:txBody>
+          <a:bodyPr wrap="square" lIns="0" tIns="0" rIns="0" bIns="0" rtlCol="0" anchor="ctr"/>
+          <a:lstStyle/>
+          <a:p>
+            <a:pPr indent="0" marL="0">
+              <a:buNone/>
+            </a:pPr>
+            <a:r>
+              <a:rPr lang="en-US" sz="950" b="1" spc="200" kern="0" dirty="0">
+                <a:solidFill>
+                  <a:srgbClr val="A65F00"/>
+                </a:solidFill>
+              </a:rPr>
+              <a:t>MODEL A — REGRESSION</a:t>
+            </a:r>
+            <a:endParaRPr lang="en-US" sz="950" dirty="0"/>
+          </a:p>
+        </p:txBody>
+      </p:sp>
+      <p:sp>
+        <p:nvSpPr>
+          <p:cNvPr id="6" name="Text 4"/>
+          <p:cNvSpPr txBox="1"/>
+          <p:nvPr/>
+        </p:nvSpPr>
+        <p:spPr>
+          <a:xfrm>
+            <a:off x="685800" y="1572768"/>
+            <a:ext cx="3566160" cy="365760"/>
+          </a:xfrm>
+          <a:prstGeom prst="rect">
+            <a:avLst/>
+          </a:prstGeom>
+          <a:noFill/>
+          <a:ln/>
+        </p:spPr>
+        <p:txBody>
+          <a:bodyPr wrap="square" lIns="0" tIns="0" rIns="0" bIns="0" rtlCol="0" anchor="ctr"/>
+          <a:lstStyle/>
+          <a:p>
+            <a:pPr indent="0" marL="0">
+              <a:buNone/>
+            </a:pPr>
+            <a:r>
+              <a:rPr lang="en-US" sz="1700" b="1" dirty="0">
+                <a:solidFill>
+                  <a:srgbClr val="14213D"/>
+                </a:solidFill>
+                <a:latin typeface="Cambria" pitchFamily="34" charset="0"/>
+                <a:ea typeface="Cambria" pitchFamily="34" charset="-122"/>
+                <a:cs typeface="Cambria" pitchFamily="34" charset="-120"/>
+              </a:rPr>
+              <a:t>Trip duration (ETA)</a:t>
+            </a:r>
+            <a:endParaRPr lang="en-US" sz="1700" dirty="0"/>
+          </a:p>
+        </p:txBody>
+      </p:sp>
+      <p:sp>
+        <p:nvSpPr>
+          <p:cNvPr id="7" name="Text 5"/>
+          <p:cNvSpPr txBox="1"/>
+          <p:nvPr/>
+        </p:nvSpPr>
+        <p:spPr>
+          <a:xfrm>
+            <a:off x="685800" y="1938528"/>
+            <a:ext cx="3566160" cy="256032"/>
+          </a:xfrm>
+          <a:prstGeom prst="rect">
+            <a:avLst/>
+          </a:prstGeom>
+          <a:noFill/>
+          <a:ln/>
+        </p:spPr>
+        <p:txBody>
+          <a:bodyPr wrap="square" lIns="0" tIns="0" rIns="0" bIns="0" rtlCol="0" anchor="ctr"/>
+          <a:lstStyle/>
+          <a:p>
+            <a:pPr indent="0" marL="0">
+              <a:buNone/>
+            </a:pPr>
+            <a:r>
+              <a:rPr lang="en-US" sz="1100" i="1" dirty="0">
+                <a:solidFill>
+                  <a:srgbClr val="5B6577"/>
+                </a:solidFill>
+              </a:rPr>
+              <a:t>Random Forest regressor · 80 trees, depth 12</a:t>
+            </a:r>
+            <a:endParaRPr lang="en-US" sz="1100" dirty="0"/>
+          </a:p>
+        </p:txBody>
+      </p:sp>
+      <p:sp>
+        <p:nvSpPr>
+          <p:cNvPr id="8" name="Text 6"/>
+          <p:cNvSpPr txBox="1"/>
+          <p:nvPr/>
+        </p:nvSpPr>
+        <p:spPr>
+          <a:xfrm>
+            <a:off x="685800" y="2258568"/>
+            <a:ext cx="3611880" cy="1188720"/>
+          </a:xfrm>
+          <a:prstGeom prst="rect">
+            <a:avLst/>
+          </a:prstGeom>
+          <a:noFill/>
+          <a:ln/>
+        </p:spPr>
+        <p:txBody>
+          <a:bodyPr wrap="square" lIns="0" tIns="0" rIns="0" bIns="0" rtlCol="0" anchor="t"/>
+          <a:lstStyle/>
+          <a:p>
+            <a:pPr marL="342900" indent="-342900">
+              <a:spcAft>
+                <a:spcPts val="600"/>
+              </a:spcAft>
+              <a:buSzPct val="100000"/>
+              <a:buChar char="•"/>
+            </a:pPr>
+            <a:r>
+              <a:rPr lang="en-US" sz="1150" dirty="0">
+                <a:solidFill>
+                  <a:srgbClr val="1B2433"/>
+                </a:solidFill>
+                <a:latin typeface="Calibri" pitchFamily="34" charset="0"/>
+                <a:ea typeface="Calibri" pitchFamily="34" charset="-122"/>
+                <a:cs typeface="Calibri" pitchFamily="34" charset="-120"/>
+              </a:rPr>
+              <a:t>Features: vehicle, distance, hour, day, traffic factor, rain</a:t>
+            </a:r>
+            <a:endParaRPr lang="en-US" sz="1150" dirty="0"/>
+          </a:p>
+          <a:p>
+            <a:pPr marL="342900" indent="-342900">
+              <a:spcAft>
+                <a:spcPts val="600"/>
+              </a:spcAft>
+              <a:buSzPct val="100000"/>
+              <a:buChar char="•"/>
+            </a:pPr>
+            <a:r>
+              <a:rPr lang="en-US" sz="1150" dirty="0">
+                <a:solidFill>
+                  <a:srgbClr val="1B2433"/>
+                </a:solidFill>
+                <a:latin typeface="Calibri" pitchFamily="34" charset="0"/>
+                <a:ea typeface="Calibri" pitchFamily="34" charset="-122"/>
+                <a:cs typeface="Calibri" pitchFamily="34" charset="-120"/>
+              </a:rPr>
+              <a:t>Learns actual ÷ formula ETA, so long trips still scale by vehicle</a:t>
+            </a:r>
+            <a:endParaRPr lang="en-US" sz="1150" dirty="0"/>
+          </a:p>
+          <a:p>
+            <a:pPr marL="342900" indent="-342900">
+              <a:spcAft>
+                <a:spcPts val="600"/>
+              </a:spcAft>
+              <a:buSzPct val="100000"/>
+              <a:buChar char="•"/>
+            </a:pPr>
+            <a:r>
+              <a:rPr lang="en-US" sz="1150" dirty="0">
+                <a:solidFill>
+                  <a:srgbClr val="1B2433"/>
+                </a:solidFill>
+                <a:latin typeface="Calibri" pitchFamily="34" charset="0"/>
+                <a:ea typeface="Calibri" pitchFamily="34" charset="-122"/>
+                <a:cs typeface="Calibri" pitchFamily="34" charset="-120"/>
+              </a:rPr>
+              <a:t>Fare is then computed from the ETA via the rate card</a:t>
+            </a:r>
+            <a:endParaRPr lang="en-US" sz="1150" dirty="0"/>
+          </a:p>
+        </p:txBody>
+      </p:sp>
+      <p:sp>
+        <p:nvSpPr>
+          <p:cNvPr id="9" name="Text 7"/>
+          <p:cNvSpPr txBox="1"/>
+          <p:nvPr/>
+        </p:nvSpPr>
+        <p:spPr>
+          <a:xfrm>
+            <a:off x="594360" y="3566160"/>
+            <a:ext cx="1828800" cy="457200"/>
+          </a:xfrm>
+          <a:prstGeom prst="rect">
+            <a:avLst/>
+          </a:prstGeom>
+          <a:noFill/>
+          <a:ln/>
+        </p:spPr>
+        <p:txBody>
+          <a:bodyPr wrap="square" lIns="0" tIns="0" rIns="0" bIns="0" rtlCol="0" anchor="ctr"/>
+          <a:lstStyle/>
+          <a:p>
+            <a:pPr algn="ctr" indent="0" marL="0">
+              <a:buNone/>
+            </a:pPr>
+            <a:r>
+              <a:rPr lang="en-US" sz="2200" b="1" dirty="0">
+                <a:solidFill>
+                  <a:srgbClr val="1B2433"/>
+                </a:solidFill>
+                <a:latin typeface="Cambria" pitchFamily="34" charset="0"/>
+                <a:ea typeface="Cambria" pitchFamily="34" charset="-122"/>
+                <a:cs typeface="Cambria" pitchFamily="34" charset="-120"/>
+              </a:rPr>
+              <a:t>2.995 min</a:t>
+            </a:r>
+            <a:endParaRPr lang="en-US" sz="2200" dirty="0"/>
+          </a:p>
+        </p:txBody>
+      </p:sp>
+      <p:sp>
+        <p:nvSpPr>
+          <p:cNvPr id="10" name="Text 8"/>
+          <p:cNvSpPr txBox="1"/>
+          <p:nvPr/>
+        </p:nvSpPr>
+        <p:spPr>
+          <a:xfrm>
+            <a:off x="594360" y="4023360"/>
+            <a:ext cx="1828800" cy="274320"/>
+          </a:xfrm>
+          <a:prstGeom prst="rect">
+            <a:avLst/>
+          </a:prstGeom>
+          <a:noFill/>
+          <a:ln/>
+        </p:spPr>
+        <p:txBody>
+          <a:bodyPr wrap="square" lIns="0" tIns="0" rIns="0" bIns="0" rtlCol="0" anchor="ctr"/>
+          <a:lstStyle/>
+          <a:p>
+            <a:pPr algn="ctr" indent="0" marL="0">
+              <a:buNone/>
+            </a:pPr>
+            <a:r>
+              <a:rPr lang="en-US" sz="1050" dirty="0">
+                <a:solidFill>
+                  <a:srgbClr val="5B6577"/>
+                </a:solidFill>
+              </a:rPr>
+              <a:t>Mean absolute error</a:t>
+            </a:r>
+            <a:endParaRPr lang="en-US" sz="1050" dirty="0"/>
+          </a:p>
+        </p:txBody>
+      </p:sp>
+      <p:sp>
+        <p:nvSpPr>
+          <p:cNvPr id="11" name="Text 9"/>
+          <p:cNvSpPr txBox="1"/>
+          <p:nvPr/>
+        </p:nvSpPr>
+        <p:spPr>
+          <a:xfrm>
+            <a:off x="2468880" y="3566160"/>
+            <a:ext cx="1828800" cy="457200"/>
+          </a:xfrm>
+          <a:prstGeom prst="rect">
+            <a:avLst/>
+          </a:prstGeom>
+          <a:noFill/>
+          <a:ln/>
+        </p:spPr>
+        <p:txBody>
+          <a:bodyPr wrap="square" lIns="0" tIns="0" rIns="0" bIns="0" rtlCol="0" anchor="ctr"/>
+          <a:lstStyle/>
+          <a:p>
+            <a:pPr algn="ctr" indent="0" marL="0">
+              <a:buNone/>
+            </a:pPr>
+            <a:r>
+              <a:rPr lang="en-US" sz="2200" b="1" dirty="0">
+                <a:solidFill>
+                  <a:srgbClr val="1B2433"/>
+                </a:solidFill>
+                <a:latin typeface="Cambria" pitchFamily="34" charset="0"/>
+                <a:ea typeface="Cambria" pitchFamily="34" charset="-122"/>
+                <a:cs typeface="Cambria" pitchFamily="34" charset="-120"/>
+              </a:rPr>
+              <a:t>0.957</a:t>
+            </a:r>
+            <a:endParaRPr lang="en-US" sz="2200" dirty="0"/>
+          </a:p>
+        </p:txBody>
+      </p:sp>
+      <p:sp>
+        <p:nvSpPr>
+          <p:cNvPr id="12" name="Text 10"/>
+          <p:cNvSpPr txBox="1"/>
+          <p:nvPr/>
+        </p:nvSpPr>
+        <p:spPr>
+          <a:xfrm>
+            <a:off x="2468880" y="4023360"/>
+            <a:ext cx="1828800" cy="274320"/>
+          </a:xfrm>
+          <a:prstGeom prst="rect">
+            <a:avLst/>
+          </a:prstGeom>
+          <a:noFill/>
+          <a:ln/>
+        </p:spPr>
+        <p:txBody>
+          <a:bodyPr wrap="square" lIns="0" tIns="0" rIns="0" bIns="0" rtlCol="0" anchor="ctr"/>
+          <a:lstStyle/>
+          <a:p>
+            <a:pPr algn="ctr" indent="0" marL="0">
+              <a:buNone/>
+            </a:pPr>
+            <a:r>
+              <a:rPr lang="en-US" sz="1050" dirty="0">
+                <a:solidFill>
+                  <a:srgbClr val="5B6577"/>
+                </a:solidFill>
+              </a:rPr>
+              <a:t>R² score</a:t>
+            </a:r>
+            <a:endParaRPr lang="en-US" sz="1050" dirty="0"/>
+          </a:p>
+        </p:txBody>
+      </p:sp>
+      <p:sp>
+        <p:nvSpPr>
+          <p:cNvPr id="13" name="Shape 11"/>
+          <p:cNvSpPr/>
+          <p:nvPr/>
+        </p:nvSpPr>
+        <p:spPr>
+          <a:xfrm>
+            <a:off x="4663440" y="1188720"/>
+            <a:ext cx="4023360" cy="3337560"/>
+          </a:xfrm>
+          <a:prstGeom prst="roundRect">
+            <a:avLst>
+              <a:gd name="adj" fmla="val 2192"/>
+            </a:avLst>
+          </a:prstGeom>
+          <a:solidFill>
+            <a:srgbClr val="EEF2F7"/>
+          </a:solidFill>
+          <a:ln w="12700">
+            <a:solidFill>
+              <a:srgbClr val="EEF2F7"/>
+            </a:solidFill>
+            <a:prstDash val="solid"/>
+          </a:ln>
+        </p:spPr>
+      </p:sp>
+      <p:sp>
+        <p:nvSpPr>
+          <p:cNvPr id="14" name="Text 12"/>
+          <p:cNvSpPr txBox="1"/>
+          <p:nvPr/>
+        </p:nvSpPr>
+        <p:spPr>
+          <a:xfrm>
+            <a:off x="4892040" y="1325880"/>
+            <a:ext cx="3566160" cy="228600"/>
+          </a:xfrm>
+          <a:prstGeom prst="rect">
+            <a:avLst/>
+          </a:prstGeom>
+          <a:noFill/>
+          <a:ln/>
+        </p:spPr>
+        <p:txBody>
+          <a:bodyPr wrap="square" lIns="0" tIns="0" rIns="0" bIns="0" rtlCol="0" anchor="ctr"/>
+          <a:lstStyle/>
+          <a:p>
+            <a:pPr indent="0" marL="0">
+              <a:buNone/>
+            </a:pPr>
+            <a:r>
+              <a:rPr lang="en-US" sz="950" b="1" spc="200" kern="0" dirty="0">
+                <a:solidFill>
+                  <a:srgbClr val="A65F00"/>
+                </a:solidFill>
+              </a:rPr>
+              <a:t>MODEL B — CLASSIFICATION</a:t>
+            </a:r>
+            <a:endParaRPr lang="en-US" sz="950" dirty="0"/>
+          </a:p>
+        </p:txBody>
+      </p:sp>
+      <p:sp>
+        <p:nvSpPr>
+          <p:cNvPr id="15" name="Text 13"/>
+          <p:cNvSpPr txBox="1"/>
+          <p:nvPr/>
+        </p:nvSpPr>
+        <p:spPr>
+          <a:xfrm>
+            <a:off x="4892040" y="1572768"/>
+            <a:ext cx="3566160" cy="365760"/>
+          </a:xfrm>
+          <a:prstGeom prst="rect">
+            <a:avLst/>
+          </a:prstGeom>
+          <a:noFill/>
+          <a:ln/>
+        </p:spPr>
+        <p:txBody>
+          <a:bodyPr wrap="square" lIns="0" tIns="0" rIns="0" bIns="0" rtlCol="0" anchor="ctr"/>
+          <a:lstStyle/>
+          <a:p>
+            <a:pPr indent="0" marL="0">
+              <a:buNone/>
+            </a:pPr>
+            <a:r>
+              <a:rPr lang="en-US" sz="1700" b="1" dirty="0">
+                <a:solidFill>
+                  <a:srgbClr val="14213D"/>
+                </a:solidFill>
+                <a:latin typeface="Cambria" pitchFamily="34" charset="0"/>
+                <a:ea typeface="Cambria" pitchFamily="34" charset="-122"/>
+                <a:cs typeface="Cambria" pitchFamily="34" charset="-120"/>
+              </a:rPr>
+              <a:t>Zone demand level → surge</a:t>
+            </a:r>
+            <a:endParaRPr lang="en-US" sz="1700" dirty="0"/>
+          </a:p>
+        </p:txBody>
+      </p:sp>
+      <p:sp>
+        <p:nvSpPr>
+          <p:cNvPr id="16" name="Text 14"/>
+          <p:cNvSpPr txBox="1"/>
+          <p:nvPr/>
+        </p:nvSpPr>
+        <p:spPr>
+          <a:xfrm>
+            <a:off x="4892040" y="1938528"/>
+            <a:ext cx="3566160" cy="256032"/>
+          </a:xfrm>
+          <a:prstGeom prst="rect">
+            <a:avLst/>
+          </a:prstGeom>
+          <a:noFill/>
+          <a:ln/>
+        </p:spPr>
+        <p:txBody>
+          <a:bodyPr wrap="square" lIns="0" tIns="0" rIns="0" bIns="0" rtlCol="0" anchor="ctr"/>
+          <a:lstStyle/>
+          <a:p>
+            <a:pPr indent="0" marL="0">
+              <a:buNone/>
+            </a:pPr>
+            <a:r>
+              <a:rPr lang="en-US" sz="1100" i="1" dirty="0">
+                <a:solidFill>
+                  <a:srgbClr val="5B6577"/>
+                </a:solidFill>
+              </a:rPr>
+              <a:t>Random Forest classifier · Low / Medium / High</a:t>
+            </a:r>
+            <a:endParaRPr lang="en-US" sz="1100" dirty="0"/>
+          </a:p>
+        </p:txBody>
+      </p:sp>
+      <p:sp>
+        <p:nvSpPr>
+          <p:cNvPr id="17" name="Text 15"/>
+          <p:cNvSpPr txBox="1"/>
+          <p:nvPr/>
+        </p:nvSpPr>
+        <p:spPr>
+          <a:xfrm>
+            <a:off x="4892040" y="2258568"/>
+            <a:ext cx="3611880" cy="1188720"/>
+          </a:xfrm>
+          <a:prstGeom prst="rect">
+            <a:avLst/>
+          </a:prstGeom>
+          <a:noFill/>
+          <a:ln/>
+        </p:spPr>
+        <p:txBody>
+          <a:bodyPr wrap="square" lIns="0" tIns="0" rIns="0" bIns="0" rtlCol="0" anchor="t"/>
+          <a:lstStyle/>
+          <a:p>
+            <a:pPr marL="342900" indent="-342900">
+              <a:spcAft>
+                <a:spcPts val="600"/>
+              </a:spcAft>
+              <a:buSzPct val="100000"/>
+              <a:buChar char="•"/>
+            </a:pPr>
+            <a:r>
+              <a:rPr lang="en-US" sz="1150" dirty="0">
+                <a:solidFill>
+                  <a:srgbClr val="1B2433"/>
+                </a:solidFill>
+                <a:latin typeface="Calibri" pitchFamily="34" charset="0"/>
+                <a:ea typeface="Calibri" pitchFamily="34" charset="-122"/>
+                <a:cs typeface="Calibri" pitchFamily="34" charset="-120"/>
+              </a:rPr>
+              <a:t>Trained on 38,158 MapReduce Job 4 cells</a:t>
+            </a:r>
+            <a:endParaRPr lang="en-US" sz="1150" dirty="0"/>
+          </a:p>
+          <a:p>
+            <a:pPr marL="342900" indent="-342900">
+              <a:spcAft>
+                <a:spcPts val="600"/>
+              </a:spcAft>
+              <a:buSzPct val="100000"/>
+              <a:buChar char="•"/>
+            </a:pPr>
+            <a:r>
+              <a:rPr lang="en-US" sz="1150" dirty="0">
+                <a:solidFill>
+                  <a:srgbClr val="1B2433"/>
+                </a:solidFill>
+                <a:latin typeface="Calibri" pitchFamily="34" charset="0"/>
+                <a:ea typeface="Calibri" pitchFamily="34" charset="-122"/>
+                <a:cs typeface="Calibri" pitchFamily="34" charset="-120"/>
+              </a:rPr>
+              <a:t>Features: hour, day, weekend, peak, zone, rain</a:t>
+            </a:r>
+            <a:endParaRPr lang="en-US" sz="1150" dirty="0"/>
+          </a:p>
+          <a:p>
+            <a:pPr marL="342900" indent="-342900">
+              <a:spcAft>
+                <a:spcPts val="600"/>
+              </a:spcAft>
+              <a:buSzPct val="100000"/>
+              <a:buChar char="•"/>
+            </a:pPr>
+            <a:r>
+              <a:rPr lang="en-US" sz="1150" dirty="0">
+                <a:solidFill>
+                  <a:srgbClr val="1B2433"/>
+                </a:solidFill>
+                <a:latin typeface="Calibri" pitchFamily="34" charset="0"/>
+                <a:ea typeface="Calibri" pitchFamily="34" charset="-122"/>
+                <a:cs typeface="Calibri" pitchFamily="34" charset="-120"/>
+              </a:rPr>
+              <a:t>Tertile labels: Low ≤ 4, Medium ≤ 8, High &gt; 8 trips / hour</a:t>
+            </a:r>
+            <a:endParaRPr lang="en-US" sz="1150" dirty="0"/>
+          </a:p>
+        </p:txBody>
+      </p:sp>
+      <p:sp>
+        <p:nvSpPr>
+          <p:cNvPr id="18" name="Text 16"/>
+          <p:cNvSpPr txBox="1"/>
+          <p:nvPr/>
+        </p:nvSpPr>
+        <p:spPr>
+          <a:xfrm>
+            <a:off x="4800600" y="3566160"/>
+            <a:ext cx="1828800" cy="457200"/>
+          </a:xfrm>
+          <a:prstGeom prst="rect">
+            <a:avLst/>
+          </a:prstGeom>
+          <a:noFill/>
+          <a:ln/>
+        </p:spPr>
+        <p:txBody>
+          <a:bodyPr wrap="square" lIns="0" tIns="0" rIns="0" bIns="0" rtlCol="0" anchor="ctr"/>
+          <a:lstStyle/>
+          <a:p>
+            <a:pPr algn="ctr" indent="0" marL="0">
+              <a:buNone/>
+            </a:pPr>
+            <a:r>
+              <a:rPr lang="en-US" sz="2200" b="1" dirty="0">
+                <a:solidFill>
+                  <a:srgbClr val="1B2433"/>
+                </a:solidFill>
+                <a:latin typeface="Cambria" pitchFamily="34" charset="0"/>
+                <a:ea typeface="Cambria" pitchFamily="34" charset="-122"/>
+                <a:cs typeface="Cambria" pitchFamily="34" charset="-120"/>
+              </a:rPr>
+              <a:t>68.0%</a:t>
+            </a:r>
+            <a:endParaRPr lang="en-US" sz="2200" dirty="0"/>
+          </a:p>
+        </p:txBody>
+      </p:sp>
+      <p:sp>
+        <p:nvSpPr>
+          <p:cNvPr id="19" name="Text 17"/>
+          <p:cNvSpPr txBox="1"/>
+          <p:nvPr/>
+        </p:nvSpPr>
+        <p:spPr>
+          <a:xfrm>
+            <a:off x="4800600" y="4023360"/>
+            <a:ext cx="1828800" cy="274320"/>
+          </a:xfrm>
+          <a:prstGeom prst="rect">
+            <a:avLst/>
+          </a:prstGeom>
+          <a:noFill/>
+          <a:ln/>
+        </p:spPr>
+        <p:txBody>
+          <a:bodyPr wrap="square" lIns="0" tIns="0" rIns="0" bIns="0" rtlCol="0" anchor="ctr"/>
+          <a:lstStyle/>
+          <a:p>
+            <a:pPr algn="ctr" indent="0" marL="0">
+              <a:buNone/>
+            </a:pPr>
+            <a:r>
+              <a:rPr lang="en-US" sz="1050" dirty="0">
+                <a:solidFill>
+                  <a:srgbClr val="5B6577"/>
+                </a:solidFill>
+              </a:rPr>
+              <a:t>Accuracy (random = 33%)</a:t>
+            </a:r>
+            <a:endParaRPr lang="en-US" sz="1050" dirty="0"/>
+          </a:p>
+        </p:txBody>
+      </p:sp>
+      <p:sp>
+        <p:nvSpPr>
+          <p:cNvPr id="20" name="Text 18"/>
+          <p:cNvSpPr txBox="1"/>
+          <p:nvPr/>
+        </p:nvSpPr>
+        <p:spPr>
+          <a:xfrm>
+            <a:off x="6675120" y="3566160"/>
+            <a:ext cx="1828800" cy="457200"/>
+          </a:xfrm>
+          <a:prstGeom prst="rect">
+            <a:avLst/>
+          </a:prstGeom>
+          <a:noFill/>
+          <a:ln/>
+        </p:spPr>
+        <p:txBody>
+          <a:bodyPr wrap="square" lIns="0" tIns="0" rIns="0" bIns="0" rtlCol="0" anchor="ctr"/>
+          <a:lstStyle/>
+          <a:p>
+            <a:pPr algn="ctr" indent="0" marL="0">
+              <a:buNone/>
+            </a:pPr>
+            <a:r>
+              <a:rPr lang="en-US" sz="2200" b="1" dirty="0">
+                <a:solidFill>
+                  <a:srgbClr val="1B2433"/>
+                </a:solidFill>
+                <a:latin typeface="Cambria" pitchFamily="34" charset="0"/>
+                <a:ea typeface="Cambria" pitchFamily="34" charset="-122"/>
+                <a:cs typeface="Cambria" pitchFamily="34" charset="-120"/>
+              </a:rPr>
+              <a:t>0.687</a:t>
+            </a:r>
+            <a:endParaRPr lang="en-US" sz="2200" dirty="0"/>
+          </a:p>
+        </p:txBody>
+      </p:sp>
+      <p:sp>
+        <p:nvSpPr>
+          <p:cNvPr id="21" name="Text 19"/>
+          <p:cNvSpPr txBox="1"/>
+          <p:nvPr/>
+        </p:nvSpPr>
+        <p:spPr>
+          <a:xfrm>
+            <a:off x="6675120" y="4023360"/>
+            <a:ext cx="1828800" cy="274320"/>
+          </a:xfrm>
+          <a:prstGeom prst="rect">
+            <a:avLst/>
+          </a:prstGeom>
+          <a:noFill/>
+          <a:ln/>
+        </p:spPr>
+        <p:txBody>
+          <a:bodyPr wrap="square" lIns="0" tIns="0" rIns="0" bIns="0" rtlCol="0" anchor="ctr"/>
+          <a:lstStyle/>
+          <a:p>
+            <a:pPr algn="ctr" indent="0" marL="0">
+              <a:buNone/>
+            </a:pPr>
+            <a:r>
+              <a:rPr lang="en-US" sz="1050" dirty="0">
+                <a:solidFill>
+                  <a:srgbClr val="5B6577"/>
+                </a:solidFill>
+              </a:rPr>
+              <a:t>Weighted F1</a:t>
+            </a:r>
+            <a:endParaRPr lang="en-US" sz="1050" dirty="0"/>
+          </a:p>
+        </p:txBody>
+      </p:sp>
+      <p:sp>
+        <p:nvSpPr>
+          <p:cNvPr id="25" name="Slide Number Placeholder 0"/>
+          <p:cNvSpPr>
+            <a:spLocks noGrp="1"/>
+          </p:cNvSpPr>
+          <p:nvPr>
+            <p:ph type="sldNum" sz="quarter" idx="4294967295"/>
+          </p:nvPr>
+        </p:nvSpPr>
+        <p:spPr>
+          <a:xfrm>
+            <a:off x="8229600" y="4754880"/>
+            <a:ext cx="457200" cy="274320"/>
+          </a:xfrm>
+          <a:prstGeom prst="rect">
+            <a:avLst/>
+          </a:prstGeom>
+          <a:extLst>
+            <a:ext uri="{C572A759-6A51-4108-AA02-DFA0A04FC94B}">
+              <ma14:wrappingTextBoxFlag xmlns:ma14="http://schemas.microsoft.com/office/mac/drawingml/2011/main" val="0"/>
+            </a:ext>
+          </a:extLst>
+        </p:spPr>
+        <p:txBody>
+          <a:bodyPr/>
+          <a:lstStyle>
+            <a:lvl1pPr>
+              <a:defRPr sz="900">
+                <a:solidFill>
+                  <a:srgbClr val="5B6577"/>
+                </a:solidFill>
+                <a:latin typeface="Calibri"/>
+                <a:ea typeface="Calibri"/>
+                <a:cs typeface="Calibri"/>
+              </a:defRPr>
+            </a:lvl1pPr>
+          </a:lstStyle>
+          <a:p>
+            <a:pPr algn="r"/>
+            <a:fld id="{F7021451-1387-4CA6-816F-3879F97B5CBC}" type="slidenum">
+              <a:rPr b="0" lang="en-US"/>
+              <a:t>9</a:t>
             </a:fld>
             <a:endParaRPr lang="en-US"/>
           </a:p>

</xml_diff>